<commit_message>
Clean up comments, fix data scripts, add licence, update deliverables
</commit_message>
<xml_diff>
--- a/deliverables/Floc_Size_Prediction_Slides.pptx
+++ b/deliverables/Floc_Size_Prediction_Slides.pptx
@@ -120,39 +120,39 @@
   <p:extLst>
     <p:ext uri="{521415D9-36F7-43E2-AB2F-B90AF26B5E84}">
       <p14:sectionLst xmlns:p14="http://schemas.microsoft.com/office/powerpoint/2010/main">
-        <p14:section name="Introduction" id="{f6540f57-116c-ce88-6618-0fd8c4cdcf0d}">
+        <p14:section name="Introduction" id="{b122db28-292b-de11-9101-9902a0bb56d8}">
           <p14:sldIdLst>
             <p14:sldId id="256"/>
             <p14:sldId id="257"/>
           </p14:sldIdLst>
         </p14:section>
-        <p14:section name="Background" id="{b88fc387-5e27-1c5d-7bc3-aa7ff4c2b97c}">
+        <p14:section name="Background" id="{3e6e5554-a96b-999b-d2d4-9dbb5978c920}">
           <p14:sldIdLst>
             <p14:sldId id="258"/>
             <p14:sldId id="259"/>
           </p14:sldIdLst>
         </p14:section>
-        <p14:section name="Approach" id="{bfc6b971-5027-e942-81ef-5d20cd6c9708}">
+        <p14:section name="Approach" id="{2e10fca3-020b-c95b-96ae-179bc34d2a9f}">
           <p14:sldIdLst>
             <p14:sldId id="260"/>
             <p14:sldId id="261"/>
             <p14:sldId id="262"/>
           </p14:sldIdLst>
         </p14:section>
-        <p14:section name="Model" id="{b1b68a48-3cd4-59aa-e439-9abf7f59e5ac}">
+        <p14:section name="Model" id="{294b9fe3-cb60-d932-67a2-5daf68d823eb}">
           <p14:sldIdLst>
             <p14:sldId id="263"/>
             <p14:sldId id="264"/>
           </p14:sldIdLst>
         </p14:section>
-        <p14:section name="Results" id="{98722e04-20f3-a4b3-4ac7-ed5a9657511d}">
+        <p14:section name="Results" id="{e4336308-27d2-e145-63fc-43a44577ddfa}">
           <p14:sldIdLst>
             <p14:sldId id="265"/>
             <p14:sldId id="266"/>
             <p14:sldId id="267"/>
           </p14:sldIdLst>
         </p14:section>
-        <p14:section name="Conclusions" id="{212bacfc-8443-396f-8571-9770ee295b81}">
+        <p14:section name="Conclusions" id="{56f62a8a-7bb2-290b-1cc3-d04fd8eb61b6}">
           <p14:sldIdLst>
             <p14:sldId id="268"/>
             <p14:sldId id="269"/>
@@ -562,7 +562,7 @@
           <a:p>
             <a:r>
               <a:rPr lang="en-US" dirty="0"/>
-              <a:t>Introduce the project: we try to predict the size of mud flocs in San Francisco Bay using only physical measurements, and we compare against a published journal paper and an internal class project by the same author.</a:t>
+              <a:t/>
             </a:r>
             <a:endParaRPr lang="en-US" dirty="0"/>
           </a:p>
@@ -650,7 +650,7 @@
           <a:p>
             <a:r>
               <a:rPr lang="en-US" dirty="0"/>
-              <a:t>The same features score 0.64 on a random split but 0.34 when whole stretches of time are held out. Single-season models do not beat guessing the average. Our copy of the class-paper setup reaches 0.60 against its reported 0.81; the gap is mostly the missing particle-type input.</a:t>
+              <a:t/>
             </a:r>
             <a:endParaRPr lang="en-US" dirty="0"/>
           </a:p>
@@ -738,7 +738,7 @@
           <a:p>
             <a:r>
               <a:rPr lang="en-US" dirty="0"/>
-              <a:t>Permutation importance: shuffle one feature at a time on held-out data and see how much accuracy drops. The two physical drivers from the journal paper come out on top. Salinity and temperature mostly act as a season label.</a:t>
+              <a:t/>
             </a:r>
             <a:endParaRPr lang="en-US" dirty="0"/>
           </a:p>
@@ -826,7 +826,7 @@
           <a:p>
             <a:r>
               <a:rPr lang="en-US" dirty="0"/>
-              <a:t>The model tracks the short tidal oscillations but misses slow, multi-day changes in floc size. That is exactly where biology matters, according to the journal paper.</a:t>
+              <a:t/>
             </a:r>
             <a:endParaRPr lang="en-US" dirty="0"/>
           </a:p>
@@ -914,7 +914,7 @@
           <a:p>
             <a:r>
               <a:rPr lang="en-US" dirty="0"/>
-              <a:t>Four takeaways. Be honest that the predictive accuracy is modest, and explain that this is a finding, not a failure: it shows what physics can and cannot do, and why the published numbers look higher.</a:t>
+              <a:t/>
             </a:r>
             <a:endParaRPr lang="en-US" dirty="0"/>
           </a:p>
@@ -1002,7 +1002,7 @@
           <a:p>
             <a:r>
               <a:rPr lang="en-US" dirty="0"/>
-              <a:t>Side by side. Measured the way each paper measured it, our scores land close: 0.17 to 0.43 against the journal's 0.15 to 0.65, and 0.60 against the class paper's 0.81. The three reasons for the remaining gap are missing biology inputs, the scoring method, and the measurement location.</a:t>
+              <a:t/>
             </a:r>
             <a:endParaRPr lang="en-US" dirty="0"/>
           </a:p>
@@ -1090,7 +1090,7 @@
           <a:p>
             <a:r>
               <a:rPr lang="en-US" dirty="0"/>
-              <a:t>Frame it as a regression problem: tabular inputs, one continuous output. The key twist is the test: we care about new days and new seasons, not just a good fit.</a:t>
+              <a:t/>
             </a:r>
             <a:endParaRPr lang="en-US" dirty="0"/>
           </a:p>
@@ -1178,7 +1178,7 @@
           <a:p>
             <a:r>
               <a:rPr lang="en-US" dirty="0"/>
-              <a:t>Motivation for a CS audience: floc size is an input every sediment transport model needs, it varies a lot, and it is expensive to measure. A predictive model would be useful.</a:t>
+              <a:t/>
             </a:r>
             <a:endParaRPr lang="en-US" dirty="0"/>
           </a:p>
@@ -1266,7 +1266,7 @@
           <a:p>
             <a:r>
               <a:rPr lang="en-US" dirty="0"/>
-              <a:t>Domain theory in one slide. Flocs are clumps of mud and organic matter. Three processes: aggregation, breakup by shear, and transport by the tide. Stokes law shows why size matters so much: settling speed scales with diameter squared.</a:t>
+              <a:t/>
             </a:r>
             <a:endParaRPr lang="en-US" dirty="0"/>
           </a:p>
@@ -1354,7 +1354,7 @@
           <a:p>
             <a:r>
               <a:rPr lang="en-US" dirty="0"/>
-              <a:t>Public dataset from the Stanford Digital Repository. We downloaded only the files we needed with HTTP range requests. Emphasise what is missing: the biology sensors.</a:t>
+              <a:t/>
             </a:r>
             <a:endParaRPr lang="en-US" dirty="0"/>
           </a:p>
@@ -1442,7 +1442,7 @@
           <a:p>
             <a:r>
               <a:rPr lang="en-US" dirty="0"/>
-              <a:t>Target engineering follows the journal paper exactly. Features: the six physical variables we could rebuild from the public data. Wave velocity is computed from the frequency spectrum of the current meter signal and checked against linear wave theory (r about 0.95).</a:t>
+              <a:t/>
             </a:r>
             <a:endParaRPr lang="en-US" dirty="0"/>
           </a:p>
@@ -1530,7 +1530,7 @@
           <a:p>
             <a:r>
               <a:rPr lang="en-US" dirty="0"/>
-              <a:t>Walk through the pipeline left to right. Each box is a file in the repo. For the live demo we run build_features.py once (about 30 s) and then run_random_forest.py, which prints the comparison table.</a:t>
+              <a:t/>
             </a:r>
             <a:endParaRPr lang="en-US" dirty="0"/>
           </a:p>
@@ -1618,7 +1618,7 @@
           <a:p>
             <a:r>
               <a:rPr lang="en-US" dirty="0"/>
-              <a:t>Main slide. We kept the Random Forest from the internal paper so our numbers are directly comparable, and because it fits small, noisy, non-linear tabular data well. We also ran LASSO, which the journal paper used, and SVR, the internal paper's other model. Be upfront about the two weaknesses: no extrapolation and autocorrelated rows.</a:t>
+              <a:t/>
             </a:r>
             <a:endParaRPr lang="en-US" dirty="0"/>
           </a:p>
@@ -1706,7 +1706,7 @@
           <a:p>
             <a:r>
               <a:rPr lang="en-US" dirty="0"/>
-              <a:t>This is the most important methodological choice. Hourly floc size changes slowly, so a random split lets the model see the hour before and after every test hour. Time-blocked splits remove whole stretches, which is how a real forecast would be used. Leave-one-season-out is the hardest test.</a:t>
+              <a:t/>
             </a:r>
             <a:endParaRPr lang="en-US" dirty="0"/>
           </a:p>
@@ -2580,6 +2580,23 @@
             </a:r>
             <a:endParaRPr lang="en-US" sz="1800" dirty="0"/>
           </a:p>
+          <a:p>
+            <a:pPr indent="0" marL="0">
+              <a:buNone/>
+            </a:pPr>
+            <a:r>
+              <a:rPr lang="en-US" sz="1400" b="1" dirty="0">
+                <a:solidFill>
+                  <a:schemeClr val="bg2"/>
+                </a:solidFill>
+                <a:latin typeface="Calibri" pitchFamily="34" charset="0"/>
+                <a:ea typeface="Calibri" pitchFamily="34" charset="-122"/>
+                <a:cs typeface="Calibri" pitchFamily="34" charset="-120"/>
+              </a:rPr>
+              <a:t>ML Mini Project, Team 7</a:t>
+            </a:r>
+            <a:endParaRPr lang="en-US" sz="1800" dirty="0"/>
+          </a:p>
         </p:txBody>
       </p:sp>
     </p:spTree>
@@ -3278,7 +3295,7 @@
                   <a:schemeClr val="tx1"/>
                 </a:solidFill>
               </a:rPr>
-              <a:t>honest accuracy across all seasons (95% interval 0.15 to 0.49)</a:t>
+              <a:t>accuracy on unseen time periods, all seasons (95% interval 0.15 to 0.49)</a:t>
             </a:r>
             <a:endParaRPr lang="en-US" sz="1400" dirty="0"/>
           </a:p>
@@ -4515,7 +4532,7 @@
       </p:sp>
       <p:sp>
         <p:nvSpPr>
-          <p:cNvPr id="5" name="Takeaway card"/>
+          <p:cNvPr id="5" name="Summary card"/>
           <p:cNvSpPr/>
           <p:nvPr/>
         </p:nvSpPr>
@@ -5194,7 +5211,7 @@
                   <a:schemeClr val="bg2"/>
                 </a:solidFill>
               </a:rPr>
-              <a:t>Next step: add the same team's Dryad optics data (15 cm sizer, particle-type index) for a closer replication.</a:t>
+              <a:t>Next step: the same group's optics data on Dryad, which lists a 15 cm sizer and a particle-type index.</a:t>
             </a:r>
             <a:endParaRPr lang="en-US" sz="1200" dirty="0"/>
           </a:p>
@@ -5945,7 +5962,7 @@
                             <a:schemeClr val="tx1"/>
                           </a:solidFill>
                         </a:rPr>
-                        <a:t>Same as journal</a:t>
+                        <a:t>Single optics platform</a:t>
                       </a:r>
                       <a:endParaRPr lang="en-US" sz="1200" dirty="0"/>
                     </a:p>
@@ -7947,7 +7964,7 @@
                   <a:schemeClr val="tx1"/>
                 </a:solidFill>
               </a:rPr>
-              <a:t>Bigger flocs sink faster. Speed grows with diameter squared, so a 2x error in size is a 4x error in where mud settles.</a:t>
+              <a:t>Bigger flocs sink faster. Speed grows with diameter squared, so a 2x error in size is a 4x error in settling speed.</a:t>
             </a:r>
             <a:endParaRPr lang="en-US" sz="1400" dirty="0"/>
           </a:p>
@@ -8274,7 +8291,7 @@
                   <a:schemeClr val="accent2"/>
                 </a:solidFill>
               </a:rPr>
-              <a:t>The gap: </a:t>
+              <a:t>The problem: </a:t>
             </a:r>
             <a:pPr indent="0" marL="0">
               <a:spcAft>
@@ -9064,7 +9081,7 @@
                   <a:schemeClr val="tx1"/>
                 </a:solidFill>
               </a:rPr>
-              <a:t>Double d and the floc sinks about 4x faster</a:t>
+              <a:t>Double d at the same density and it sinks 4x faster</a:t>
             </a:r>
             <a:endParaRPr lang="en-US" sz="1400" dirty="0"/>
           </a:p>
@@ -13311,7 +13328,7 @@
                   <a:schemeClr val="tx1"/>
                 </a:solidFill>
               </a:rPr>
-              <a:t>Same model as the internal CS229 study, so scores compare directly (32 trees, default settings)</a:t>
+              <a:t>Same model as Egan's CS229 report, so scores compare directly (32 trees, default settings)</a:t>
             </a:r>
             <a:endParaRPr lang="en-US" sz="1400" dirty="0"/>
           </a:p>
@@ -13564,7 +13581,7 @@
                   <a:schemeClr val="accent6"/>
                 </a:solidFill>
               </a:rPr>
-              <a:t>Watch-outs: </a:t>
+              <a:t>Limitations: </a:t>
             </a:r>
             <a:pPr indent="0" marL="0">
               <a:spcAft>
@@ -15076,7 +15093,7 @@
                   <a:schemeClr val="tx1"/>
                 </a:solidFill>
               </a:rPr>
-              <a:t>Whole multi-day stretches held out with a 12 h gap. Honest forecast test (ours)</a:t>
+              <a:t>Whole multi-day stretches held out with a 12 h gap. Closest to real forecasting (ours)</a:t>
             </a:r>
             <a:endParaRPr lang="en-US" sz="1300" dirty="0"/>
           </a:p>

</xml_diff>